<commit_message>
Checkpoint: PPT V5 Round 2修复：1) 空内容检测增强 - bullets存在但为空数组也算无内容，强制切换key_points布局 2) per-section fallback - 每个bullet_list section若bullets为空自动生成3条fallback 3) comparison渲染层防御 - 空bullets时显示标签而非空白 4) 23个vitest全部通过
</commit_message>
<xml_diff>
--- a/test-output.pptx
+++ b/test-output.pptx
@@ -1711,7 +1711,7 @@
                   <a:srgbClr val="FFFFFF"/>
                 </a:solidFill>
               </a:rPr>
-              <a:t>2025/12/9</a:t>
+              <a:t>2026/2/26</a:t>
             </a:r>
             <a:endParaRPr lang="en-US" sz="1400" dirty="0"/>
           </a:p>
@@ -2024,7 +2024,7 @@
                   <a:srgbClr val="9CA3AF"/>
                 </a:solidFill>
               </a:rPr>
-              <a:t>2025/12/9</a:t>
+              <a:t>2026/2/26</a:t>
             </a:r>
             <a:endParaRPr lang="en-US" sz="1000" dirty="0"/>
           </a:p>
@@ -2354,7 +2354,7 @@
                   <a:srgbClr val="9CA3AF"/>
                 </a:solidFill>
               </a:rPr>
-              <a:t>2025/12/9</a:t>
+              <a:t>2026/2/26</a:t>
             </a:r>
             <a:endParaRPr lang="en-US" sz="1000" dirty="0"/>
           </a:p>
@@ -2667,7 +2667,7 @@
                   <a:srgbClr val="9CA3AF"/>
                 </a:solidFill>
               </a:rPr>
-              <a:t>2025/12/9</a:t>
+              <a:t>2026/2/26</a:t>
             </a:r>
             <a:endParaRPr lang="en-US" sz="1000" dirty="0"/>
           </a:p>
@@ -2980,7 +2980,7 @@
                   <a:srgbClr val="9CA3AF"/>
                 </a:solidFill>
               </a:rPr>
-              <a:t>2025/12/9</a:t>
+              <a:t>2026/2/26</a:t>
             </a:r>
             <a:endParaRPr lang="en-US" sz="1000" dirty="0"/>
           </a:p>
@@ -3233,7 +3233,7 @@
                   <a:srgbClr val="9CA3AF"/>
                 </a:solidFill>
               </a:rPr>
-              <a:t>2025/12/9</a:t>
+              <a:t>2026/2/26</a:t>
             </a:r>
             <a:endParaRPr lang="en-US" sz="1000" dirty="0"/>
           </a:p>
@@ -3537,7 +3537,7 @@
                   <a:srgbClr val="9CA3AF"/>
                 </a:solidFill>
               </a:rPr>
-              <a:t>2025/12/9</a:t>
+              <a:t>2026/2/26</a:t>
             </a:r>
             <a:endParaRPr lang="en-US" sz="1000" dirty="0"/>
           </a:p>
@@ -3824,7 +3824,7 @@
                   <a:srgbClr val="9CA3AF"/>
                 </a:solidFill>
               </a:rPr>
-              <a:t>2025/12/9</a:t>
+              <a:t>2026/2/26</a:t>
             </a:r>
             <a:endParaRPr lang="en-US" sz="1000" dirty="0"/>
           </a:p>

</xml_diff>